<commit_message>
Tuesday: tighten to VAP language (operationalize/define, not 'reading'); instruments tied to the value being analysed (slop=beauty, METUX=autonomy, HRI=trust, UEQ=UX); deliverable = value-centered user RESEARCH deck + a FigJam reflection. Team decks: prefill each team's declared Project 2 value + app (Security/Safety/Sustainability&Trust/Care/Productivity; Fixr Findr TBD)
Co-Authored-By: Claude Fable 5 <noreply@anthropic.com>
</commit_message>
<xml_diff>
--- a/slides/Week3-Tue-User-Testing-II.pptx
+++ b/slides/Week3-Tue-User-Testing-II.pptx
@@ -5233,7 +5233,7 @@
                 </a:solidFill>
                 <a:latin typeface="Arial"/>
               </a:rPr>
-              <a:t>Your reading decides your design AND your test. (That is yesterday's move - and today's.)</a:t>
+              <a:t>Your operational definition decides your design AND your test. (That is yesterday's move - and today's.)</a:t>
             </a:r>
           </a:p>
         </p:txBody>
@@ -10088,7 +10088,7 @@
                 </a:solidFill>
                 <a:latin typeface="Courier New"/>
               </a:rPr>
-              <a:t>MEASURE BEYOND USABILITY</a:t>
+              <a:t>PICK THE INSTRUMENT THAT FITS YOUR VALUE</a:t>
             </a:r>
           </a:p>
         </p:txBody>
@@ -10171,7 +10171,7 @@
                 </a:solidFill>
                 <a:latin typeface="Arial"/>
               </a:rPr>
-              <a:t>Instruments that make a value legible</a:t>
+              <a:t>Examples - tie the tool to the value you are analyzing</a:t>
             </a:r>
           </a:p>
         </p:txBody>
@@ -10219,7 +10219,7 @@
                 </a:solidFill>
                 <a:latin typeface="Arial"/>
               </a:rPr>
-              <a:t>UEQ - attractiveness, novelty, stimulation, beyond just "usable".</a:t>
+              <a:t>Beauty / craft / originality -&gt; the Vibed Slop Detector (is it generic AI slop?), or UEQ attractiveness.</a:t>
             </a:r>
           </a:p>
           <a:p>
@@ -10244,7 +10244,7 @@
                 </a:solidFill>
                 <a:latin typeface="Arial"/>
               </a:rPr>
-              <a:t>HRI Scale Database / METUX + SDT scales - trust, autonomy, competence, relatedness.</a:t>
+              <a:t>Autonomy / competence / wellbeing -&gt; METUX + Self-Determination scales.</a:t>
             </a:r>
           </a:p>
           <a:p>
@@ -10269,7 +10269,7 @@
                 </a:solidFill>
                 <a:latin typeface="Arial"/>
               </a:rPr>
-              <a:t>Vibed Slop Detector - generic AI "slop" as a proxy for missing craft and care.</a:t>
+              <a:t>Trust / warmth / safety -&gt; a validated scale from the HRI Scale Database.</a:t>
             </a:r>
           </a:p>
           <a:p>
@@ -10294,7 +10294,7 @@
                 </a:solidFill>
                 <a:latin typeface="Arial"/>
               </a:rPr>
-              <a:t>Match the instrument to your reading of the value - run the right one.</a:t>
+              <a:t>Overall UX beyond usability -&gt; UEQ. The instrument has to match the value - don't default to UEQ.</a:t>
             </a:r>
           </a:p>
         </p:txBody>
@@ -11794,7 +11794,7 @@
                 </a:solidFill>
                 <a:latin typeface="Arial"/>
               </a:rPr>
-              <a:t>Pick the reading of your value you actually designed for - it decides the method.</a:t>
+              <a:t>State how you operationalize your value - that definition decides the method.</a:t>
             </a:r>
           </a:p>
           <a:p>
@@ -11819,7 +11819,7 @@
                 </a:solidFill>
                 <a:latin typeface="Arial"/>
               </a:rPr>
-              <a:t>Choose the lens + instrument that reading demands, and run a quick check.</a:t>
+              <a:t>Choose the lens + instrument that definition demands, and run a quick check.</a:t>
             </a:r>
           </a:p>
           <a:p>
@@ -11938,7 +11938,7 @@
                 </a:solidFill>
                 <a:latin typeface="Arial"/>
               </a:rPr>
-              <a:t>Team research deck + verification canvas - each person owns a named slide + a lane - due today</a:t>
+              <a:t>A value-centered user RESEARCH deck + a reflection on FigJam - each person owns a slide + a lane - due today</a:t>
             </a:r>
           </a:p>
         </p:txBody>

</xml_diff>